<commit_message>
docs: update submission deck with live public Cloud Run URL
New URL: disha-backend-564262191703.asia-south1.run.app (gowthamaccount project — no org policy)

Co-Authored-By: Claude Sonnet 4.6 <noreply@anthropic.com>
</commit_message>
<xml_diff>
--- a/Project_Disha_IDBI_Innovate_2026.pptx
+++ b/Project_Disha_IDBI_Innovate_2026.pptx
@@ -9102,7 +9102,7 @@
                 </a:solidFill>
                 <a:latin typeface="Calibri"/>
               </a:rPr>
-              <a:t>https://disha-backend-1012823692058.asia-south1.run.app</a:t>
+              <a:t>https://disha-backend-564262191703.asia-south1.run.app</a:t>
             </a:r>
           </a:p>
         </p:txBody>
@@ -9297,7 +9297,7 @@
                 </a:solidFill>
                 <a:latin typeface="Calibri"/>
               </a:rPr>
-              <a:t>https://disha-backend-1012823692058.asia-south1.run.app/health</a:t>
+              <a:t>https://disha-backend-564262191703.asia-south1.run.app/health</a:t>
             </a:r>
           </a:p>
         </p:txBody>
@@ -9492,7 +9492,7 @@
                 </a:solidFill>
                 <a:latin typeface="Calibri"/>
               </a:rPr>
-              <a:t>https://disha-backend-1012823692058.asia-south1.run.app/docs</a:t>
+              <a:t>https://disha-backend-564262191703.asia-south1.run.app/docs</a:t>
             </a:r>
           </a:p>
         </p:txBody>

</xml_diff>